<commit_message>
Added slide showing gold standard list.
</commit_message>
<xml_diff>
--- a/reports/2026-02-19_projectUpdate_1_jmoran.pptx
+++ b/reports/2026-02-19_projectUpdate_1_jmoran.pptx
@@ -209,7 +209,7 @@
           <a:p>
             <a:fld id="{F0213E3E-99C3-4924-8BC9-8C32863166AD}" type="datetimeFigureOut">
               <a:rPr lang="en-CA" smtClean="0"/>
-              <a:t>2026-02-19</a:t>
+              <a:t>2026-04-01</a:t>
             </a:fld>
             <a:endParaRPr lang="en-CA"/>
           </a:p>
@@ -909,7 +909,7 @@
           <a:p>
             <a:fld id="{DB80BDBF-4DC5-4E43-8386-3D3A42895B61}" type="datetime1">
               <a:rPr lang="en-CA" smtClean="0"/>
-              <a:t>2026-02-19</a:t>
+              <a:t>2026-04-01</a:t>
             </a:fld>
             <a:endParaRPr lang="en-CA"/>
           </a:p>
@@ -1114,7 +1114,7 @@
           <a:p>
             <a:fld id="{17ED8303-E57F-4CA4-B509-8D7861A88550}" type="datetime1">
               <a:rPr lang="en-CA" smtClean="0"/>
-              <a:t>2026-02-19</a:t>
+              <a:t>2026-04-01</a:t>
             </a:fld>
             <a:endParaRPr lang="en-CA"/>
           </a:p>
@@ -1324,7 +1324,7 @@
           <a:p>
             <a:fld id="{F7F1FC32-9D3D-4364-92A5-9AA79CCC701C}" type="datetime1">
               <a:rPr lang="en-CA" smtClean="0"/>
-              <a:t>2026-02-19</a:t>
+              <a:t>2026-04-01</a:t>
             </a:fld>
             <a:endParaRPr lang="en-CA"/>
           </a:p>
@@ -1524,7 +1524,7 @@
           <a:p>
             <a:fld id="{8AE818EC-6326-4BA8-9805-A8FC86ABE731}" type="datetime1">
               <a:rPr lang="en-CA" smtClean="0"/>
-              <a:t>2026-02-19</a:t>
+              <a:t>2026-04-01</a:t>
             </a:fld>
             <a:endParaRPr lang="en-CA"/>
           </a:p>
@@ -1808,7 +1808,7 @@
           <a:p>
             <a:fld id="{13D3A6B3-9AB5-436E-AD8B-49199EDCFC83}" type="datetime1">
               <a:rPr lang="en-CA" smtClean="0"/>
-              <a:t>2026-02-19</a:t>
+              <a:t>2026-04-01</a:t>
             </a:fld>
             <a:endParaRPr lang="en-CA"/>
           </a:p>
@@ -2076,7 +2076,7 @@
           <a:p>
             <a:fld id="{DA6D15FE-77BE-47EE-B790-AAE215F99824}" type="datetime1">
               <a:rPr lang="en-CA" smtClean="0"/>
-              <a:t>2026-02-19</a:t>
+              <a:t>2026-04-01</a:t>
             </a:fld>
             <a:endParaRPr lang="en-CA"/>
           </a:p>
@@ -2491,7 +2491,7 @@
           <a:p>
             <a:fld id="{1D4752C9-8CF6-40F0-AB13-1637EE612586}" type="datetime1">
               <a:rPr lang="en-CA" smtClean="0"/>
-              <a:t>2026-02-19</a:t>
+              <a:t>2026-04-01</a:t>
             </a:fld>
             <a:endParaRPr lang="en-CA"/>
           </a:p>
@@ -2633,7 +2633,7 @@
           <a:p>
             <a:fld id="{952F2ECE-72B5-4D96-A4B2-E67705705716}" type="datetime1">
               <a:rPr lang="en-CA" smtClean="0"/>
-              <a:t>2026-02-19</a:t>
+              <a:t>2026-04-01</a:t>
             </a:fld>
             <a:endParaRPr lang="en-CA"/>
           </a:p>
@@ -2746,7 +2746,7 @@
           <a:p>
             <a:fld id="{886B9229-C469-40E9-86E2-8A75D5BC886F}" type="datetime1">
               <a:rPr lang="en-CA" smtClean="0"/>
-              <a:t>2026-02-19</a:t>
+              <a:t>2026-04-01</a:t>
             </a:fld>
             <a:endParaRPr lang="en-CA"/>
           </a:p>
@@ -3059,7 +3059,7 @@
           <a:p>
             <a:fld id="{1000E48D-DAFA-4AD7-87A4-FFF723385EC7}" type="datetime1">
               <a:rPr lang="en-CA" smtClean="0"/>
-              <a:t>2026-02-19</a:t>
+              <a:t>2026-04-01</a:t>
             </a:fld>
             <a:endParaRPr lang="en-CA"/>
           </a:p>
@@ -3348,7 +3348,7 @@
           <a:p>
             <a:fld id="{725286D7-AAE8-4192-93AF-4124B82BCBD4}" type="datetime1">
               <a:rPr lang="en-CA" smtClean="0"/>
-              <a:t>2026-02-19</a:t>
+              <a:t>2026-04-01</a:t>
             </a:fld>
             <a:endParaRPr lang="en-CA"/>
           </a:p>
@@ -3591,7 +3591,7 @@
           <a:p>
             <a:fld id="{6141495A-2B01-4521-BD4F-D3958705F056}" type="datetime1">
               <a:rPr lang="en-CA" smtClean="0"/>
-              <a:t>2026-02-19</a:t>
+              <a:t>2026-04-01</a:t>
             </a:fld>
             <a:endParaRPr lang="en-CA"/>
           </a:p>
@@ -7058,8 +7058,8 @@
           </a:p>
         </p:txBody>
       </p:sp>
-      <mc:AlternateContent xmlns:mc="http://schemas.openxmlformats.org/markup-compatibility/2006">
-        <mc:Choice xmlns:a14="http://schemas.microsoft.com/office/drawing/2010/main" Requires="a14">
+      <mc:AlternateContent xmlns:mc="http://schemas.openxmlformats.org/markup-compatibility/2006" xmlns:a14="http://schemas.microsoft.com/office/drawing/2010/main">
+        <mc:Choice Requires="a14">
           <p:sp>
             <p:nvSpPr>
               <p:cNvPr id="5" name="TextBox 4">
@@ -7227,7 +7227,7 @@
             </p:txBody>
           </p:sp>
         </mc:Choice>
-        <mc:Fallback>
+        <mc:Fallback xmlns="">
           <p:sp>
             <p:nvSpPr>
               <p:cNvPr id="5" name="TextBox 4">
@@ -11388,10 +11388,10 @@
           <p:nvPr/>
         </p:nvPicPr>
         <p:blipFill>
-          <a:blip r:embed="rId2">
+          <a:blip>
             <a:extLst>
               <a:ext uri="{96DAC541-7B7A-43D3-8B79-37D633B846F1}">
-                <asvg:svgBlip xmlns:asvg="http://schemas.microsoft.com/office/drawing/2016/SVG/main" r:embed="rId3"/>
+                <asvg:svgBlip xmlns:asvg="http://schemas.microsoft.com/office/drawing/2016/SVG/main" r:embed="rId2"/>
               </a:ext>
             </a:extLst>
           </a:blip>
@@ -11538,10 +11538,10 @@
           <p:nvPr/>
         </p:nvPicPr>
         <p:blipFill>
-          <a:blip r:embed="rId2">
+          <a:blip>
             <a:extLst>
               <a:ext uri="{96DAC541-7B7A-43D3-8B79-37D633B846F1}">
-                <asvg:svgBlip xmlns:asvg="http://schemas.microsoft.com/office/drawing/2016/SVG/main" r:embed="rId3"/>
+                <asvg:svgBlip xmlns:asvg="http://schemas.microsoft.com/office/drawing/2016/SVG/main" r:embed="rId2"/>
               </a:ext>
             </a:extLst>
           </a:blip>
@@ -13848,7 +13848,7 @@
                         <a:buNone/>
                       </a:pPr>
                       <a:r>
-                        <a:rPr lang="en-CA" sz="1200" b="0" i="0" u="none" strike="noStrike">
+                        <a:rPr lang="en-CA" sz="1200" b="0" i="0" u="none" strike="noStrike" dirty="0">
                           <a:solidFill>
                             <a:srgbClr val="000000"/>
                           </a:solidFill>

</xml_diff>